<commit_message>
Last modifications (on defense)
</commit_message>
<xml_diff>
--- a/A_Documentation/Defense.pptx
+++ b/A_Documentation/Defense.pptx
@@ -225,7 +225,7 @@
           <a:p>
             <a:fld id="{C6333347-8B99-4D12-8D18-1FE76537B012}" type="datetimeFigureOut">
               <a:rPr lang="fr-CH" smtClean="0"/>
-              <a:t>06.09.2026</a:t>
+              <a:t>07.09.2026</a:t>
             </a:fld>
             <a:endParaRPr lang="fr-CH"/>
           </a:p>
@@ -642,7 +642,7 @@
           <a:p>
             <a:fld id="{4402F845-7D1D-4BC7-9D07-41BA32719176}" type="datetime1">
               <a:rPr lang="fr-CH" smtClean="0"/>
-              <a:t>06.09.2026</a:t>
+              <a:t>07.09.2026</a:t>
             </a:fld>
             <a:endParaRPr lang="fr-CH"/>
           </a:p>
@@ -842,7 +842,7 @@
           <a:p>
             <a:fld id="{14CC4612-9EF6-4B04-A368-185401C2C328}" type="datetime1">
               <a:rPr lang="fr-CH" smtClean="0"/>
-              <a:t>06.09.2026</a:t>
+              <a:t>07.09.2026</a:t>
             </a:fld>
             <a:endParaRPr lang="fr-CH"/>
           </a:p>
@@ -1053,7 +1053,7 @@
           <a:p>
             <a:fld id="{14CC4612-9EF6-4B04-A368-185401C2C328}" type="datetime1">
               <a:rPr lang="fr-CH" smtClean="0"/>
-              <a:t>06.09.2026</a:t>
+              <a:t>07.09.2026</a:t>
             </a:fld>
             <a:endParaRPr lang="fr-CH"/>
           </a:p>
@@ -1254,7 +1254,7 @@
           <a:p>
             <a:fld id="{B00C96F7-2F60-4A9F-A586-72D490FA45D0}" type="datetime1">
               <a:rPr lang="fr-CH" smtClean="0"/>
-              <a:t>06.09.2026</a:t>
+              <a:t>07.09.2026</a:t>
             </a:fld>
             <a:endParaRPr lang="fr-CH"/>
           </a:p>
@@ -1530,7 +1530,7 @@
           <a:p>
             <a:fld id="{14CC4612-9EF6-4B04-A368-185401C2C328}" type="datetime1">
               <a:rPr lang="fr-CH" smtClean="0"/>
-              <a:t>06.09.2026</a:t>
+              <a:t>07.09.2026</a:t>
             </a:fld>
             <a:endParaRPr lang="fr-CH"/>
           </a:p>
@@ -1799,7 +1799,7 @@
           <a:p>
             <a:fld id="{14CC4612-9EF6-4B04-A368-185401C2C328}" type="datetime1">
               <a:rPr lang="fr-CH" smtClean="0"/>
-              <a:t>06.09.2026</a:t>
+              <a:t>07.09.2026</a:t>
             </a:fld>
             <a:endParaRPr lang="fr-CH"/>
           </a:p>
@@ -2215,7 +2215,7 @@
           <a:p>
             <a:fld id="{14CC4612-9EF6-4B04-A368-185401C2C328}" type="datetime1">
               <a:rPr lang="fr-CH" smtClean="0"/>
-              <a:t>06.09.2026</a:t>
+              <a:t>07.09.2026</a:t>
             </a:fld>
             <a:endParaRPr lang="fr-CH"/>
           </a:p>
@@ -2358,7 +2358,7 @@
           <a:p>
             <a:fld id="{14CC4612-9EF6-4B04-A368-185401C2C328}" type="datetime1">
               <a:rPr lang="fr-CH" smtClean="0"/>
-              <a:t>06.09.2026</a:t>
+              <a:t>07.09.2026</a:t>
             </a:fld>
             <a:endParaRPr lang="fr-CH"/>
           </a:p>
@@ -2472,7 +2472,7 @@
           <a:p>
             <a:fld id="{14CC4612-9EF6-4B04-A368-185401C2C328}" type="datetime1">
               <a:rPr lang="fr-CH" smtClean="0"/>
-              <a:t>06.09.2026</a:t>
+              <a:t>07.09.2026</a:t>
             </a:fld>
             <a:endParaRPr lang="fr-CH"/>
           </a:p>
@@ -2786,7 +2786,7 @@
           <a:p>
             <a:fld id="{14CC4612-9EF6-4B04-A368-185401C2C328}" type="datetime1">
               <a:rPr lang="fr-CH" smtClean="0"/>
-              <a:t>06.09.2026</a:t>
+              <a:t>07.09.2026</a:t>
             </a:fld>
             <a:endParaRPr lang="fr-CH"/>
           </a:p>
@@ -3076,7 +3076,7 @@
           <a:p>
             <a:fld id="{14CC4612-9EF6-4B04-A368-185401C2C328}" type="datetime1">
               <a:rPr lang="fr-CH" smtClean="0"/>
-              <a:t>06.09.2026</a:t>
+              <a:t>07.09.2026</a:t>
             </a:fld>
             <a:endParaRPr lang="fr-CH"/>
           </a:p>
@@ -3320,7 +3320,7 @@
           <a:p>
             <a:fld id="{14CC4612-9EF6-4B04-A368-185401C2C328}" type="datetime1">
               <a:rPr lang="fr-CH" smtClean="0"/>
-              <a:t>06.09.2026</a:t>
+              <a:t>07.09.2026</a:t>
             </a:fld>
             <a:endParaRPr lang="fr-CH"/>
           </a:p>
@@ -3813,7 +3813,7 @@
                 <a:latin typeface="Space Grotesk" pitchFamily="2" charset="0"/>
                 <a:cs typeface="Space Grotesk" pitchFamily="2" charset="0"/>
               </a:rPr>
-              <a:t>GE EEM</a:t>
+              <a:t>GE TIN EEM</a:t>
             </a:r>
           </a:p>
           <a:p>
@@ -5085,6 +5085,11 @@
             </a:lvl9pPr>
           </a:lstStyle>
           <a:p>
+            <a:pPr>
+              <a:lnSpc>
+                <a:spcPct val="150000"/>
+              </a:lnSpc>
+            </a:pPr>
             <a:r>
               <a:rPr lang="en-US" dirty="0">
                 <a:latin typeface="Space Grotesk" pitchFamily="2" charset="0"/>
@@ -5094,6 +5099,11 @@
             </a:r>
           </a:p>
           <a:p>
+            <a:pPr>
+              <a:lnSpc>
+                <a:spcPct val="150000"/>
+              </a:lnSpc>
+            </a:pPr>
             <a:r>
               <a:rPr lang="en-US" dirty="0">
                 <a:latin typeface="Space Grotesk" pitchFamily="2" charset="0"/>
@@ -5103,6 +5113,11 @@
             </a:r>
           </a:p>
           <a:p>
+            <a:pPr>
+              <a:lnSpc>
+                <a:spcPct val="150000"/>
+              </a:lnSpc>
+            </a:pPr>
             <a:r>
               <a:rPr lang="en-US" dirty="0">
                 <a:latin typeface="Space Grotesk" pitchFamily="2" charset="0"/>
@@ -6016,6 +6031,11 @@
           <a:bodyPr/>
           <a:lstStyle/>
           <a:p>
+            <a:pPr>
+              <a:lnSpc>
+                <a:spcPct val="150000"/>
+              </a:lnSpc>
+            </a:pPr>
             <a:r>
               <a:rPr lang="en-US" dirty="0">
                 <a:latin typeface="Space Grotesk" pitchFamily="2" charset="0"/>
@@ -6036,6 +6056,11 @@
             </a:endParaRPr>
           </a:p>
           <a:p>
+            <a:pPr>
+              <a:lnSpc>
+                <a:spcPct val="150000"/>
+              </a:lnSpc>
+            </a:pPr>
             <a:r>
               <a:rPr lang="en-US" dirty="0" err="1">
                 <a:latin typeface="Space Grotesk" pitchFamily="2" charset="0"/>
@@ -6063,6 +6088,11 @@
             </a:endParaRPr>
           </a:p>
           <a:p>
+            <a:pPr>
+              <a:lnSpc>
+                <a:spcPct val="150000"/>
+              </a:lnSpc>
+            </a:pPr>
             <a:r>
               <a:rPr lang="en-US" dirty="0" err="1">
                 <a:latin typeface="Space Grotesk" pitchFamily="2" charset="0"/>
@@ -6090,6 +6120,41 @@
                 <a:cs typeface="Space Grotesk" pitchFamily="2" charset="0"/>
               </a:rPr>
               <a:t> du chassis</a:t>
+            </a:r>
+          </a:p>
+          <a:p>
+            <a:pPr>
+              <a:lnSpc>
+                <a:spcPct val="150000"/>
+              </a:lnSpc>
+            </a:pPr>
+            <a:r>
+              <a:rPr lang="en-US" dirty="0" err="1">
+                <a:latin typeface="Space Grotesk" pitchFamily="2" charset="0"/>
+                <a:cs typeface="Space Grotesk" pitchFamily="2" charset="0"/>
+              </a:rPr>
+              <a:t>Adhérence</a:t>
+            </a:r>
+            <a:r>
+              <a:rPr lang="en-US" dirty="0">
+                <a:latin typeface="Space Grotesk" pitchFamily="2" charset="0"/>
+                <a:cs typeface="Space Grotesk" pitchFamily="2" charset="0"/>
+              </a:rPr>
+              <a:t> </a:t>
+            </a:r>
+            <a:r>
+              <a:rPr lang="en-US" dirty="0" err="1">
+                <a:latin typeface="Space Grotesk" pitchFamily="2" charset="0"/>
+                <a:cs typeface="Space Grotesk" pitchFamily="2" charset="0"/>
+              </a:rPr>
+              <a:t>parfaite</a:t>
+            </a:r>
+            <a:r>
+              <a:rPr lang="en-US" dirty="0">
+                <a:latin typeface="Space Grotesk" pitchFamily="2" charset="0"/>
+                <a:cs typeface="Space Grotesk" pitchFamily="2" charset="0"/>
+              </a:rPr>
+              <a:t> au sol</a:t>
             </a:r>
           </a:p>
           <a:p>
@@ -9775,12 +9840,17 @@
           </a:p>
           <a:p>
             <a:r>
-              <a:rPr lang="fr-CH">
+              <a:rPr lang="fr-CH" dirty="0">
                 <a:latin typeface="Space Grotesk" pitchFamily="2" charset="0"/>
                 <a:cs typeface="Space Grotesk" pitchFamily="2" charset="0"/>
               </a:rPr>
               <a:t>Valeurs limites</a:t>
             </a:r>
+          </a:p>
+          <a:p>
+            <a:pPr marL="0" indent="0">
+              <a:buNone/>
+            </a:pPr>
             <a:endParaRPr lang="fr-CH" b="0" dirty="0">
               <a:latin typeface="Space Grotesk" pitchFamily="2" charset="0"/>
               <a:cs typeface="Space Grotesk" pitchFamily="2" charset="0"/>
@@ -9996,6 +10066,22 @@
           <a:bodyPr/>
           <a:lstStyle/>
           <a:p>
+            <a:pPr>
+              <a:lnSpc>
+                <a:spcPct val="150000"/>
+              </a:lnSpc>
+            </a:pPr>
+            <a:endParaRPr lang="en-US" dirty="0">
+              <a:latin typeface="Space Grotesk" pitchFamily="2" charset="0"/>
+              <a:cs typeface="Space Grotesk" pitchFamily="2" charset="0"/>
+            </a:endParaRPr>
+          </a:p>
+          <a:p>
+            <a:pPr>
+              <a:lnSpc>
+                <a:spcPct val="150000"/>
+              </a:lnSpc>
+            </a:pPr>
             <a:r>
               <a:rPr lang="en-US" dirty="0" err="1">
                 <a:latin typeface="Space Grotesk" pitchFamily="2" charset="0"/>
@@ -10040,6 +10126,11 @@
             </a:r>
           </a:p>
           <a:p>
+            <a:pPr>
+              <a:lnSpc>
+                <a:spcPct val="150000"/>
+              </a:lnSpc>
+            </a:pPr>
             <a:r>
               <a:rPr lang="en-US" dirty="0">
                 <a:latin typeface="Space Grotesk" pitchFamily="2" charset="0"/>
@@ -10074,6 +10165,27 @@
                 <a:cs typeface="Space Grotesk" pitchFamily="2" charset="0"/>
               </a:rPr>
               <a:t> pas à pas</a:t>
+            </a:r>
+          </a:p>
+          <a:p>
+            <a:pPr>
+              <a:lnSpc>
+                <a:spcPct val="150000"/>
+              </a:lnSpc>
+            </a:pPr>
+            <a:r>
+              <a:rPr lang="en-US" dirty="0" err="1">
+                <a:latin typeface="Space Grotesk" pitchFamily="2" charset="0"/>
+                <a:cs typeface="Space Grotesk" pitchFamily="2" charset="0"/>
+              </a:rPr>
+              <a:t>Régulation</a:t>
+            </a:r>
+            <a:r>
+              <a:rPr lang="en-US" dirty="0">
+                <a:latin typeface="Space Grotesk" pitchFamily="2" charset="0"/>
+                <a:cs typeface="Space Grotesk" pitchFamily="2" charset="0"/>
+              </a:rPr>
+              <a:t> LQR</a:t>
             </a:r>
           </a:p>
         </p:txBody>

</xml_diff>